<commit_message>
docs: white-theme showcase deck with embedded case videos
</commit_message>
<xml_diff>
--- a/MFC_combustion_showcase.pptx
+++ b/MFC_combustion_showcase.pptx
@@ -3112,7 +3112,7 @@
             <a:avLst/>
           </a:prstGeom>
           <a:solidFill>
-            <a:srgbClr val="0B0D13"/>
+            <a:srgbClr val="FFFFFF"/>
           </a:solidFill>
           <a:ln>
             <a:noFill/>
@@ -3171,7 +3171,7 @@
             <a:r>
               <a:rPr sz="1500" b="1">
                 <a:solidFill>
-                  <a:srgbClr val="FF7A34"/>
+                  <a:srgbClr val="C85610"/>
                 </a:solidFill>
                 <a:latin typeface="Calibri"/>
               </a:rPr>
@@ -3210,7 +3210,7 @@
             <a:r>
               <a:rPr sz="4600" b="1">
                 <a:solidFill>
-                  <a:srgbClr val="ECE9E3"/>
+                  <a:srgbClr val="1A1A1F"/>
                 </a:solidFill>
                 <a:latin typeface="Calibri"/>
               </a:rPr>
@@ -3249,7 +3249,7 @@
             <a:r>
               <a:rPr sz="1800" b="0">
                 <a:solidFill>
-                  <a:srgbClr val="9AA0AB"/>
+                  <a:srgbClr val="52525B"/>
                 </a:solidFill>
                 <a:latin typeface="Calibri"/>
               </a:rPr>
@@ -3291,7 +3291,7 @@
             <a:avLst/>
           </a:prstGeom>
           <a:solidFill>
-            <a:srgbClr val="0B0D13"/>
+            <a:srgbClr val="FFFFFF"/>
           </a:solidFill>
           <a:ln>
             <a:noFill/>
@@ -3328,8 +3328,8 @@
         </p:nvSpPr>
         <p:spPr>
           <a:xfrm>
-            <a:off x="502920" y="292608"/>
-            <a:ext cx="822960" cy="548640"/>
+            <a:off x="502920" y="274320"/>
+            <a:ext cx="1280160" cy="548640"/>
           </a:xfrm>
           <a:prstGeom prst="rect">
             <a:avLst/>
@@ -3348,13 +3348,13 @@
               </a:lnSpc>
             </a:pPr>
             <a:r>
-              <a:rPr sz="2600" b="1">
+              <a:rPr sz="2000" b="1">
                 <a:solidFill>
-                  <a:srgbClr val="F5B544"/>
+                  <a:srgbClr val="A96E08"/>
                 </a:solidFill>
                 <a:latin typeface="Calibri"/>
               </a:rPr>
-              <a:t>⚡</a:t>
+              <a:t>PERF</a:t>
             </a:r>
           </a:p>
         </p:txBody>
@@ -3367,8 +3367,8 @@
         </p:nvSpPr>
         <p:spPr>
           <a:xfrm>
-            <a:off x="1325880" y="310896"/>
-            <a:ext cx="10332720" cy="822960"/>
+            <a:off x="1600200" y="310896"/>
+            <a:ext cx="10058400" cy="822960"/>
           </a:xfrm>
           <a:prstGeom prst="rect">
             <a:avLst/>
@@ -3389,7 +3389,7 @@
             <a:r>
               <a:rPr sz="2600" b="1">
                 <a:solidFill>
-                  <a:srgbClr val="ECE9E3"/>
+                  <a:srgbClr val="1A1A1F"/>
                 </a:solidFill>
                 <a:latin typeface="Calibri"/>
               </a:rPr>
@@ -3420,6 +3420,11 @@
           <a:prstGeom prst="rect">
             <a:avLst/>
           </a:prstGeom>
+          <a:ln w="12700">
+            <a:solidFill>
+              <a:srgbClr val="CFD3DA"/>
+            </a:solidFill>
+          </a:ln>
         </p:spPr>
       </p:pic>
       <p:sp>
@@ -3452,7 +3457,7 @@
             <a:r>
               <a:rPr sz="3000" b="1">
                 <a:solidFill>
-                  <a:srgbClr val="F5B544"/>
+                  <a:srgbClr val="C85610"/>
                 </a:solidFill>
                 <a:latin typeface="Calibri"/>
               </a:rPr>
@@ -3491,7 +3496,7 @@
             <a:r>
               <a:rPr sz="1600" b="0">
                 <a:solidFill>
-                  <a:srgbClr val="9AA0AB"/>
+                  <a:srgbClr val="52525B"/>
                 </a:solidFill>
                 <a:latin typeface="Calibri"/>
               </a:rPr>
@@ -3507,7 +3512,7 @@
             <a:r>
               <a:rPr sz="1600" b="0">
                 <a:solidFill>
-                  <a:srgbClr val="9AA0AB"/>
+                  <a:srgbClr val="52525B"/>
                 </a:solidFill>
                 <a:latin typeface="Calibri"/>
               </a:rPr>
@@ -3523,7 +3528,7 @@
             <a:r>
               <a:rPr sz="1600" b="0">
                 <a:solidFill>
-                  <a:srgbClr val="9AA0AB"/>
+                  <a:srgbClr val="52525B"/>
                 </a:solidFill>
                 <a:latin typeface="Calibri"/>
               </a:rPr>
@@ -3565,7 +3570,7 @@
             <a:avLst/>
           </a:prstGeom>
           <a:solidFill>
-            <a:srgbClr val="0B0D13"/>
+            <a:srgbClr val="FFFFFF"/>
           </a:solidFill>
           <a:ln>
             <a:noFill/>
@@ -3624,7 +3629,7 @@
             <a:r>
               <a:rPr sz="2600" b="1">
                 <a:solidFill>
-                  <a:srgbClr val="FF7A34"/>
+                  <a:srgbClr val="C85610"/>
                 </a:solidFill>
                 <a:latin typeface="Calibri"/>
               </a:rPr>
@@ -3663,7 +3668,7 @@
             <a:r>
               <a:rPr sz="2600" b="1">
                 <a:solidFill>
-                  <a:srgbClr val="ECE9E3"/>
+                  <a:srgbClr val="1A1A1F"/>
                 </a:solidFill>
                 <a:latin typeface="Calibri"/>
               </a:rPr>
@@ -3674,29 +3679,38 @@
       </p:sp>
       <p:pic>
         <p:nvPicPr>
-          <p:cNvPr id="5" name="Picture 4" descr="detonation.png"/>
+          <p:cNvPr id="5" name="det.mp4">
+            <a:hlinkClick r:id="" action="ppaction://media"/>
+          </p:cNvPr>
           <p:cNvPicPr>
             <a:picLocks noChangeAspect="1"/>
           </p:cNvPicPr>
-          <p:nvPr/>
+          <p:nvPr>
+            <a:videoFile r:link="rId3"/>
+            <p:extLst>
+              <p:ext uri="{DAA4B4D4-6D71-4841-9C94-3DE7FCFB9230}">
+                <p14:media xmlns:p14="http://schemas.microsoft.com/office/powerpoint/2010/main" r:embed="rId2"/>
+              </p:ext>
+            </p:extLst>
+          </p:nvPr>
         </p:nvPicPr>
         <p:blipFill>
-          <a:blip r:embed="rId2"/>
+          <a:blip r:embed="rId4"/>
           <a:stretch>
             <a:fillRect/>
           </a:stretch>
         </p:blipFill>
         <p:spPr>
           <a:xfrm>
-            <a:off x="502920" y="1417320"/>
-            <a:ext cx="7315200" cy="3048000"/>
+            <a:off x="502920" y="1463040"/>
+            <a:ext cx="7315200" cy="3039872"/>
           </a:xfrm>
           <a:prstGeom prst="rect">
             <a:avLst/>
           </a:prstGeom>
           <a:ln w="12700">
             <a:solidFill>
-              <a:srgbClr val="2A2E38"/>
+              <a:srgbClr val="CFD3DA"/>
             </a:solidFill>
           </a:ln>
         </p:spPr>
@@ -3709,8 +3723,8 @@
         </p:nvSpPr>
         <p:spPr>
           <a:xfrm>
-            <a:off x="8092440" y="1554480"/>
-            <a:ext cx="3657600" cy="4572000"/>
+            <a:off x="8138160" y="1600200"/>
+            <a:ext cx="3611880" cy="4572000"/>
           </a:xfrm>
           <a:prstGeom prst="rect">
             <a:avLst/>
@@ -3731,7 +3745,7 @@
             <a:r>
               <a:rPr sz="1600" b="0">
                 <a:solidFill>
-                  <a:srgbClr val="9AA0AB"/>
+                  <a:srgbClr val="52525B"/>
                 </a:solidFill>
                 <a:latin typeface="Calibri"/>
               </a:rPr>
@@ -3745,6 +3759,28 @@
   <p:clrMapOvr>
     <a:masterClrMapping/>
   </p:clrMapOvr>
+  <p:timing>
+    <p:tnLst>
+      <p:par>
+        <p:cTn id="1" dur="indefinite" restart="never" nodeType="tmRoot">
+          <p:childTnLst>
+            <p:video>
+              <p:cMediaNode vol="80000">
+                <p:cTn id="2" fill="hold" display="0">
+                  <p:stCondLst>
+                    <p:cond delay="indefinite"/>
+                  </p:stCondLst>
+                </p:cTn>
+                <p:tgtEl>
+                  <p:spTgt spid="5"/>
+                </p:tgtEl>
+              </p:cMediaNode>
+            </p:video>
+          </p:childTnLst>
+        </p:cTn>
+      </p:par>
+    </p:tnLst>
+  </p:timing>
 </p:sld>
 </file>
 
@@ -3773,7 +3809,7 @@
             <a:avLst/>
           </a:prstGeom>
           <a:solidFill>
-            <a:srgbClr val="0B0D13"/>
+            <a:srgbClr val="FFFFFF"/>
           </a:solidFill>
           <a:ln>
             <a:noFill/>
@@ -3832,7 +3868,7 @@
             <a:r>
               <a:rPr sz="2600" b="1">
                 <a:solidFill>
-                  <a:srgbClr val="FF7A34"/>
+                  <a:srgbClr val="C85610"/>
                 </a:solidFill>
                 <a:latin typeface="Calibri"/>
               </a:rPr>
@@ -3871,7 +3907,7 @@
             <a:r>
               <a:rPr sz="2600" b="1">
                 <a:solidFill>
-                  <a:srgbClr val="ECE9E3"/>
+                  <a:srgbClr val="1A1A1F"/>
                 </a:solidFill>
                 <a:latin typeface="Calibri"/>
               </a:rPr>
@@ -3882,29 +3918,38 @@
       </p:sp>
       <p:pic>
         <p:nvPicPr>
-          <p:cNvPr id="5" name="Picture 4" descr="detonation_ellipse_snap.png"/>
+          <p:cNvPr id="5" name="ell.mp4">
+            <a:hlinkClick r:id="" action="ppaction://media"/>
+          </p:cNvPr>
           <p:cNvPicPr>
             <a:picLocks noChangeAspect="1"/>
           </p:cNvPicPr>
-          <p:nvPr/>
+          <p:nvPr>
+            <a:videoFile r:link="rId3"/>
+            <p:extLst>
+              <p:ext uri="{DAA4B4D4-6D71-4841-9C94-3DE7FCFB9230}">
+                <p14:media xmlns:p14="http://schemas.microsoft.com/office/powerpoint/2010/main" r:embed="rId2"/>
+              </p:ext>
+            </p:extLst>
+          </p:nvPr>
         </p:nvPicPr>
         <p:blipFill>
-          <a:blip r:embed="rId2"/>
+          <a:blip r:embed="rId4"/>
           <a:stretch>
             <a:fillRect/>
           </a:stretch>
         </p:blipFill>
         <p:spPr>
           <a:xfrm>
-            <a:off x="502920" y="1417320"/>
-            <a:ext cx="7315200" cy="2011680"/>
+            <a:off x="502920" y="1463040"/>
+            <a:ext cx="7315200" cy="1999488"/>
           </a:xfrm>
           <a:prstGeom prst="rect">
             <a:avLst/>
           </a:prstGeom>
           <a:ln w="12700">
             <a:solidFill>
-              <a:srgbClr val="2A2E38"/>
+              <a:srgbClr val="CFD3DA"/>
             </a:solidFill>
           </a:ln>
         </p:spPr>
@@ -3917,8 +3962,8 @@
         </p:nvSpPr>
         <p:spPr>
           <a:xfrm>
-            <a:off x="8092440" y="1554480"/>
-            <a:ext cx="3657600" cy="4572000"/>
+            <a:off x="8138160" y="1600200"/>
+            <a:ext cx="3611880" cy="4572000"/>
           </a:xfrm>
           <a:prstGeom prst="rect">
             <a:avLst/>
@@ -3939,7 +3984,7 @@
             <a:r>
               <a:rPr sz="1600" b="0">
                 <a:solidFill>
-                  <a:srgbClr val="9AA0AB"/>
+                  <a:srgbClr val="52525B"/>
                 </a:solidFill>
                 <a:latin typeface="Calibri"/>
               </a:rPr>
@@ -3953,6 +3998,28 @@
   <p:clrMapOvr>
     <a:masterClrMapping/>
   </p:clrMapOvr>
+  <p:timing>
+    <p:tnLst>
+      <p:par>
+        <p:cTn id="1" dur="indefinite" restart="never" nodeType="tmRoot">
+          <p:childTnLst>
+            <p:video>
+              <p:cMediaNode vol="80000">
+                <p:cTn id="2" fill="hold" display="0">
+                  <p:stCondLst>
+                    <p:cond delay="indefinite"/>
+                  </p:stCondLst>
+                </p:cTn>
+                <p:tgtEl>
+                  <p:spTgt spid="5"/>
+                </p:tgtEl>
+              </p:cMediaNode>
+            </p:video>
+          </p:childTnLst>
+        </p:cTn>
+      </p:par>
+    </p:tnLst>
+  </p:timing>
 </p:sld>
 </file>
 
@@ -3981,7 +4048,7 @@
             <a:avLst/>
           </a:prstGeom>
           <a:solidFill>
-            <a:srgbClr val="0B0D13"/>
+            <a:srgbClr val="FFFFFF"/>
           </a:solidFill>
           <a:ln>
             <a:noFill/>
@@ -4040,7 +4107,7 @@
             <a:r>
               <a:rPr sz="2600" b="1">
                 <a:solidFill>
-                  <a:srgbClr val="FF7A34"/>
+                  <a:srgbClr val="C85610"/>
                 </a:solidFill>
                 <a:latin typeface="Calibri"/>
               </a:rPr>
@@ -4079,7 +4146,7 @@
             <a:r>
               <a:rPr sz="2600" b="1">
                 <a:solidFill>
-                  <a:srgbClr val="ECE9E3"/>
+                  <a:srgbClr val="1A1A1F"/>
                 </a:solidFill>
                 <a:latin typeface="Calibri"/>
               </a:rPr>
@@ -4118,7 +4185,7 @@
             <a:r>
               <a:rPr sz="1100" b="1">
                 <a:solidFill>
-                  <a:srgbClr val="F5B544"/>
+                  <a:srgbClr val="A96E08"/>
                 </a:solidFill>
                 <a:latin typeface="Calibri"/>
               </a:rPr>
@@ -4129,29 +4196,38 @@
       </p:sp>
       <p:pic>
         <p:nvPicPr>
-          <p:cNvPr id="6" name="Picture 5" descr="reactive_burn_structure.png"/>
+          <p:cNvPr id="6" name="rb.mp4">
+            <a:hlinkClick r:id="" action="ppaction://media"/>
+          </p:cNvPr>
           <p:cNvPicPr>
             <a:picLocks noChangeAspect="1"/>
           </p:cNvPicPr>
-          <p:nvPr/>
+          <p:nvPr>
+            <a:videoFile r:link="rId3"/>
+            <p:extLst>
+              <p:ext uri="{DAA4B4D4-6D71-4841-9C94-3DE7FCFB9230}">
+                <p14:media xmlns:p14="http://schemas.microsoft.com/office/powerpoint/2010/main" r:embed="rId2"/>
+              </p:ext>
+            </p:extLst>
+          </p:nvPr>
         </p:nvPicPr>
         <p:blipFill>
-          <a:blip r:embed="rId2"/>
+          <a:blip r:embed="rId4"/>
           <a:stretch>
             <a:fillRect/>
           </a:stretch>
         </p:blipFill>
         <p:spPr>
           <a:xfrm>
-            <a:off x="1106257" y="1417320"/>
-            <a:ext cx="6108526" cy="4937760"/>
+            <a:off x="502920" y="1463040"/>
+            <a:ext cx="7315200" cy="3103968"/>
           </a:xfrm>
           <a:prstGeom prst="rect">
             <a:avLst/>
           </a:prstGeom>
           <a:ln w="12700">
             <a:solidFill>
-              <a:srgbClr val="2A2E38"/>
+              <a:srgbClr val="CFD3DA"/>
             </a:solidFill>
           </a:ln>
         </p:spPr>
@@ -4164,8 +4240,8 @@
         </p:nvSpPr>
         <p:spPr>
           <a:xfrm>
-            <a:off x="8092440" y="1554480"/>
-            <a:ext cx="3657600" cy="4572000"/>
+            <a:off x="8138160" y="1600200"/>
+            <a:ext cx="3611880" cy="4572000"/>
           </a:xfrm>
           <a:prstGeom prst="rect">
             <a:avLst/>
@@ -4186,7 +4262,7 @@
             <a:r>
               <a:rPr sz="1600" b="0">
                 <a:solidFill>
-                  <a:srgbClr val="9AA0AB"/>
+                  <a:srgbClr val="52525B"/>
                 </a:solidFill>
                 <a:latin typeface="Calibri"/>
               </a:rPr>
@@ -4200,6 +4276,28 @@
   <p:clrMapOvr>
     <a:masterClrMapping/>
   </p:clrMapOvr>
+  <p:timing>
+    <p:tnLst>
+      <p:par>
+        <p:cTn id="1" dur="indefinite" restart="never" nodeType="tmRoot">
+          <p:childTnLst>
+            <p:video>
+              <p:cMediaNode vol="80000">
+                <p:cTn id="2" fill="hold" display="0">
+                  <p:stCondLst>
+                    <p:cond delay="indefinite"/>
+                  </p:stCondLst>
+                </p:cTn>
+                <p:tgtEl>
+                  <p:spTgt spid="6"/>
+                </p:tgtEl>
+              </p:cMediaNode>
+            </p:video>
+          </p:childTnLst>
+        </p:cTn>
+      </p:par>
+    </p:tnLst>
+  </p:timing>
 </p:sld>
 </file>
 
@@ -4228,7 +4326,7 @@
             <a:avLst/>
           </a:prstGeom>
           <a:solidFill>
-            <a:srgbClr val="0B0D13"/>
+            <a:srgbClr val="FFFFFF"/>
           </a:solidFill>
           <a:ln>
             <a:noFill/>
@@ -4287,7 +4385,7 @@
             <a:r>
               <a:rPr sz="2600" b="1">
                 <a:solidFill>
-                  <a:srgbClr val="FF7A34"/>
+                  <a:srgbClr val="C85610"/>
                 </a:solidFill>
                 <a:latin typeface="Calibri"/>
               </a:rPr>
@@ -4326,7 +4424,7 @@
             <a:r>
               <a:rPr sz="2600" b="1">
                 <a:solidFill>
-                  <a:srgbClr val="ECE9E3"/>
+                  <a:srgbClr val="1A1A1F"/>
                 </a:solidFill>
                 <a:latin typeface="Calibri"/>
               </a:rPr>
@@ -4365,7 +4463,7 @@
             <a:r>
               <a:rPr sz="1100" b="1">
                 <a:solidFill>
-                  <a:srgbClr val="F5B544"/>
+                  <a:srgbClr val="A96E08"/>
                 </a:solidFill>
                 <a:latin typeface="Calibri"/>
               </a:rPr>
@@ -4376,29 +4474,38 @@
       </p:sp>
       <p:pic>
         <p:nvPicPr>
-          <p:cNvPr id="6" name="Picture 5" descr="burning_grain_snap.png"/>
+          <p:cNvPr id="6" name="grain.mp4">
+            <a:hlinkClick r:id="" action="ppaction://media"/>
+          </p:cNvPr>
           <p:cNvPicPr>
             <a:picLocks noChangeAspect="1"/>
           </p:cNvPicPr>
-          <p:nvPr/>
+          <p:nvPr>
+            <a:videoFile r:link="rId3"/>
+            <p:extLst>
+              <p:ext uri="{DAA4B4D4-6D71-4841-9C94-3DE7FCFB9230}">
+                <p14:media xmlns:p14="http://schemas.microsoft.com/office/powerpoint/2010/main" r:embed="rId2"/>
+              </p:ext>
+            </p:extLst>
+          </p:nvPr>
         </p:nvPicPr>
         <p:blipFill>
-          <a:blip r:embed="rId2"/>
+          <a:blip r:embed="rId4"/>
           <a:stretch>
             <a:fillRect/>
           </a:stretch>
         </p:blipFill>
         <p:spPr>
           <a:xfrm>
-            <a:off x="502920" y="1417320"/>
-            <a:ext cx="7315200" cy="2763520"/>
+            <a:off x="574766" y="1463040"/>
+            <a:ext cx="7171508" cy="4937760"/>
           </a:xfrm>
           <a:prstGeom prst="rect">
             <a:avLst/>
           </a:prstGeom>
           <a:ln w="12700">
             <a:solidFill>
-              <a:srgbClr val="2A2E38"/>
+              <a:srgbClr val="CFD3DA"/>
             </a:solidFill>
           </a:ln>
         </p:spPr>
@@ -4411,8 +4518,8 @@
         </p:nvSpPr>
         <p:spPr>
           <a:xfrm>
-            <a:off x="8092440" y="1554480"/>
-            <a:ext cx="3657600" cy="4572000"/>
+            <a:off x="8138160" y="1600200"/>
+            <a:ext cx="3611880" cy="4572000"/>
           </a:xfrm>
           <a:prstGeom prst="rect">
             <a:avLst/>
@@ -4433,7 +4540,7 @@
             <a:r>
               <a:rPr sz="1600" b="0">
                 <a:solidFill>
-                  <a:srgbClr val="9AA0AB"/>
+                  <a:srgbClr val="52525B"/>
                 </a:solidFill>
                 <a:latin typeface="Calibri"/>
               </a:rPr>
@@ -4447,6 +4554,28 @@
   <p:clrMapOvr>
     <a:masterClrMapping/>
   </p:clrMapOvr>
+  <p:timing>
+    <p:tnLst>
+      <p:par>
+        <p:cTn id="1" dur="indefinite" restart="never" nodeType="tmRoot">
+          <p:childTnLst>
+            <p:video>
+              <p:cMediaNode vol="80000">
+                <p:cTn id="2" fill="hold" display="0">
+                  <p:stCondLst>
+                    <p:cond delay="indefinite"/>
+                  </p:stCondLst>
+                </p:cTn>
+                <p:tgtEl>
+                  <p:spTgt spid="6"/>
+                </p:tgtEl>
+              </p:cMediaNode>
+            </p:video>
+          </p:childTnLst>
+        </p:cTn>
+      </p:par>
+    </p:tnLst>
+  </p:timing>
 </p:sld>
 </file>
 
@@ -4475,7 +4604,7 @@
             <a:avLst/>
           </a:prstGeom>
           <a:solidFill>
-            <a:srgbClr val="0B0D13"/>
+            <a:srgbClr val="FFFFFF"/>
           </a:solidFill>
           <a:ln>
             <a:noFill/>
@@ -4534,7 +4663,7 @@
             <a:r>
               <a:rPr sz="2600" b="1">
                 <a:solidFill>
-                  <a:srgbClr val="FF7A34"/>
+                  <a:srgbClr val="C85610"/>
                 </a:solidFill>
                 <a:latin typeface="Calibri"/>
               </a:rPr>
@@ -4573,7 +4702,7 @@
             <a:r>
               <a:rPr sz="2600" b="1">
                 <a:solidFill>
-                  <a:srgbClr val="ECE9E3"/>
+                  <a:srgbClr val="1A1A1F"/>
                 </a:solidFill>
                 <a:latin typeface="Calibri"/>
               </a:rPr>
@@ -4612,7 +4741,7 @@
             <a:r>
               <a:rPr sz="1100" b="1">
                 <a:solidFill>
-                  <a:srgbClr val="F5B544"/>
+                  <a:srgbClr val="A96E08"/>
                 </a:solidFill>
                 <a:latin typeface="Calibri"/>
               </a:rPr>
@@ -4623,29 +4752,38 @@
       </p:sp>
       <p:pic>
         <p:nvPicPr>
-          <p:cNvPr id="6" name="Picture 5" descr="internal_ballistics.png"/>
+          <p:cNvPr id="6" name="ib.mp4">
+            <a:hlinkClick r:id="" action="ppaction://media"/>
+          </p:cNvPr>
           <p:cNvPicPr>
             <a:picLocks noChangeAspect="1"/>
           </p:cNvPicPr>
-          <p:nvPr/>
+          <p:nvPr>
+            <a:videoFile r:link="rId3"/>
+            <p:extLst>
+              <p:ext uri="{DAA4B4D4-6D71-4841-9C94-3DE7FCFB9230}">
+                <p14:media xmlns:p14="http://schemas.microsoft.com/office/powerpoint/2010/main" r:embed="rId2"/>
+              </p:ext>
+            </p:extLst>
+          </p:nvPr>
         </p:nvPicPr>
         <p:blipFill>
-          <a:blip r:embed="rId2"/>
+          <a:blip r:embed="rId4"/>
           <a:stretch>
             <a:fillRect/>
           </a:stretch>
         </p:blipFill>
         <p:spPr>
           <a:xfrm>
-            <a:off x="502920" y="1417320"/>
-            <a:ext cx="7315200" cy="4151870"/>
+            <a:off x="627159" y="1463040"/>
+            <a:ext cx="7066721" cy="4937760"/>
           </a:xfrm>
           <a:prstGeom prst="rect">
             <a:avLst/>
           </a:prstGeom>
           <a:ln w="12700">
             <a:solidFill>
-              <a:srgbClr val="2A2E38"/>
+              <a:srgbClr val="CFD3DA"/>
             </a:solidFill>
           </a:ln>
         </p:spPr>
@@ -4658,8 +4796,8 @@
         </p:nvSpPr>
         <p:spPr>
           <a:xfrm>
-            <a:off x="8092440" y="1554480"/>
-            <a:ext cx="3657600" cy="4572000"/>
+            <a:off x="8138160" y="1600200"/>
+            <a:ext cx="3611880" cy="4572000"/>
           </a:xfrm>
           <a:prstGeom prst="rect">
             <a:avLst/>
@@ -4680,11 +4818,11 @@
             <a:r>
               <a:rPr sz="1600" b="0">
                 <a:solidFill>
-                  <a:srgbClr val="9AA0AB"/>
+                  <a:srgbClr val="52525B"/>
                 </a:solidFill>
                 <a:latin typeface="Calibri"/>
               </a:rPr>
-              <a:t>A Vieille's-law burn rate (v ∝ pⁿ) turns the closed chamber into a feedback loop: combustion raises the pressure, which raises the burn rate, which raises the pressure. The coupled case pulls ahead of constant injection — the defining signature of solid-rocket internal ballistics, from CFD.</a:t>
+              <a:t>A Vieille's-law burn rate (v ∝ pⁿ) turns the closed chamber into a feedback loop: combustion raises the pressure, which raises the burn rate, which raises the pressure — the defining signature of solid-rocket internal ballistics, reproduced from first-principles CFD.</a:t>
             </a:r>
           </a:p>
         </p:txBody>
@@ -4694,6 +4832,28 @@
   <p:clrMapOvr>
     <a:masterClrMapping/>
   </p:clrMapOvr>
+  <p:timing>
+    <p:tnLst>
+      <p:par>
+        <p:cTn id="1" dur="indefinite" restart="never" nodeType="tmRoot">
+          <p:childTnLst>
+            <p:video>
+              <p:cMediaNode vol="80000">
+                <p:cTn id="2" fill="hold" display="0">
+                  <p:stCondLst>
+                    <p:cond delay="indefinite"/>
+                  </p:stCondLst>
+                </p:cTn>
+                <p:tgtEl>
+                  <p:spTgt spid="6"/>
+                </p:tgtEl>
+              </p:cMediaNode>
+            </p:video>
+          </p:childTnLst>
+        </p:cTn>
+      </p:par>
+    </p:tnLst>
+  </p:timing>
 </p:sld>
 </file>
 
@@ -4722,7 +4882,7 @@
             <a:avLst/>
           </a:prstGeom>
           <a:solidFill>
-            <a:srgbClr val="0B0D13"/>
+            <a:srgbClr val="FFFFFF"/>
           </a:solidFill>
           <a:ln>
             <a:noFill/>
@@ -4781,7 +4941,7 @@
             <a:r>
               <a:rPr sz="2600" b="1">
                 <a:solidFill>
-                  <a:srgbClr val="FF7A34"/>
+                  <a:srgbClr val="C85610"/>
                 </a:solidFill>
                 <a:latin typeface="Calibri"/>
               </a:rPr>
@@ -4820,7 +4980,7 @@
             <a:r>
               <a:rPr sz="2600" b="1">
                 <a:solidFill>
-                  <a:srgbClr val="ECE9E3"/>
+                  <a:srgbClr val="1A1A1F"/>
                 </a:solidFill>
                 <a:latin typeface="Calibri"/>
               </a:rPr>
@@ -4831,29 +4991,38 @@
       </p:sp>
       <p:pic>
         <p:nvPicPr>
-          <p:cNvPr id="5" name="Picture 4" descr="hybrid_flame_snap.png"/>
+          <p:cNvPr id="5" name="hyb.mp4">
+            <a:hlinkClick r:id="" action="ppaction://media"/>
+          </p:cNvPr>
           <p:cNvPicPr>
             <a:picLocks noChangeAspect="1"/>
           </p:cNvPicPr>
-          <p:nvPr/>
+          <p:nvPr>
+            <a:videoFile r:link="rId3"/>
+            <p:extLst>
+              <p:ext uri="{DAA4B4D4-6D71-4841-9C94-3DE7FCFB9230}">
+                <p14:media xmlns:p14="http://schemas.microsoft.com/office/powerpoint/2010/main" r:embed="rId2"/>
+              </p:ext>
+            </p:extLst>
+          </p:nvPr>
         </p:nvPicPr>
         <p:blipFill>
-          <a:blip r:embed="rId2"/>
+          <a:blip r:embed="rId4"/>
           <a:stretch>
             <a:fillRect/>
           </a:stretch>
         </p:blipFill>
         <p:spPr>
           <a:xfrm>
-            <a:off x="502920" y="1417320"/>
-            <a:ext cx="7315199" cy="1609343"/>
+            <a:off x="502920" y="1463040"/>
+            <a:ext cx="7315200" cy="2909824"/>
           </a:xfrm>
           <a:prstGeom prst="rect">
             <a:avLst/>
           </a:prstGeom>
           <a:ln w="12700">
             <a:solidFill>
-              <a:srgbClr val="2A2E38"/>
+              <a:srgbClr val="CFD3DA"/>
             </a:solidFill>
           </a:ln>
         </p:spPr>
@@ -4866,8 +5035,8 @@
         </p:nvSpPr>
         <p:spPr>
           <a:xfrm>
-            <a:off x="8092440" y="1554480"/>
-            <a:ext cx="3657600" cy="4572000"/>
+            <a:off x="8138160" y="1600200"/>
+            <a:ext cx="3611880" cy="4572000"/>
           </a:xfrm>
           <a:prstGeom prst="rect">
             <a:avLst/>
@@ -4888,7 +5057,7 @@
             <a:r>
               <a:rPr sz="1600" b="0">
                 <a:solidFill>
-                  <a:srgbClr val="9AA0AB"/>
+                  <a:srgbClr val="52525B"/>
                 </a:solidFill>
                 <a:latin typeface="Calibri"/>
               </a:rPr>
@@ -4902,6 +5071,28 @@
   <p:clrMapOvr>
     <a:masterClrMapping/>
   </p:clrMapOvr>
+  <p:timing>
+    <p:tnLst>
+      <p:par>
+        <p:cTn id="1" dur="indefinite" restart="never" nodeType="tmRoot">
+          <p:childTnLst>
+            <p:video>
+              <p:cMediaNode vol="80000">
+                <p:cTn id="2" fill="hold" display="0">
+                  <p:stCondLst>
+                    <p:cond delay="indefinite"/>
+                  </p:stCondLst>
+                </p:cTn>
+                <p:tgtEl>
+                  <p:spTgt spid="5"/>
+                </p:tgtEl>
+              </p:cMediaNode>
+            </p:video>
+          </p:childTnLst>
+        </p:cTn>
+      </p:par>
+    </p:tnLst>
+  </p:timing>
 </p:sld>
 </file>
 
@@ -4930,7 +5121,7 @@
             <a:avLst/>
           </a:prstGeom>
           <a:solidFill>
-            <a:srgbClr val="0B0D13"/>
+            <a:srgbClr val="FFFFFF"/>
           </a:solidFill>
           <a:ln>
             <a:noFill/>
@@ -4989,7 +5180,7 @@
             <a:r>
               <a:rPr sz="2600" b="1">
                 <a:solidFill>
-                  <a:srgbClr val="FF7A34"/>
+                  <a:srgbClr val="C85610"/>
                 </a:solidFill>
                 <a:latin typeface="Calibri"/>
               </a:rPr>
@@ -5028,7 +5219,7 @@
             <a:r>
               <a:rPr sz="2600" b="1">
                 <a:solidFill>
-                  <a:srgbClr val="ECE9E3"/>
+                  <a:srgbClr val="1A1A1F"/>
                 </a:solidFill>
                 <a:latin typeface="Calibri"/>
               </a:rPr>
@@ -5039,29 +5230,38 @@
       </p:sp>
       <p:pic>
         <p:nvPicPr>
-          <p:cNvPr id="5" name="Picture 4" descr="flameholder_snap.png"/>
+          <p:cNvPr id="5" name="fh.mp4">
+            <a:hlinkClick r:id="" action="ppaction://media"/>
+          </p:cNvPr>
           <p:cNvPicPr>
             <a:picLocks noChangeAspect="1"/>
           </p:cNvPicPr>
-          <p:nvPr/>
+          <p:nvPr>
+            <a:videoFile r:link="rId3"/>
+            <p:extLst>
+              <p:ext uri="{DAA4B4D4-6D71-4841-9C94-3DE7FCFB9230}">
+                <p14:media xmlns:p14="http://schemas.microsoft.com/office/powerpoint/2010/main" r:embed="rId2"/>
+              </p:ext>
+            </p:extLst>
+          </p:nvPr>
         </p:nvPicPr>
         <p:blipFill>
-          <a:blip r:embed="rId2"/>
+          <a:blip r:embed="rId4"/>
           <a:stretch>
             <a:fillRect/>
           </a:stretch>
         </p:blipFill>
         <p:spPr>
           <a:xfrm>
-            <a:off x="502920" y="1417320"/>
-            <a:ext cx="7315199" cy="1972887"/>
+            <a:off x="502920" y="1463040"/>
+            <a:ext cx="7315200" cy="3576320"/>
           </a:xfrm>
           <a:prstGeom prst="rect">
             <a:avLst/>
           </a:prstGeom>
           <a:ln w="12700">
             <a:solidFill>
-              <a:srgbClr val="2A2E38"/>
+              <a:srgbClr val="CFD3DA"/>
             </a:solidFill>
           </a:ln>
         </p:spPr>
@@ -5074,8 +5274,8 @@
         </p:nvSpPr>
         <p:spPr>
           <a:xfrm>
-            <a:off x="8092440" y="1554480"/>
-            <a:ext cx="3657600" cy="4572000"/>
+            <a:off x="8138160" y="1600200"/>
+            <a:ext cx="3611880" cy="4572000"/>
           </a:xfrm>
           <a:prstGeom prst="rect">
             <a:avLst/>
@@ -5096,7 +5296,7 @@
             <a:r>
               <a:rPr sz="1600" b="0">
                 <a:solidFill>
-                  <a:srgbClr val="9AA0AB"/>
+                  <a:srgbClr val="52525B"/>
                 </a:solidFill>
                 <a:latin typeface="Calibri"/>
               </a:rPr>
@@ -5110,6 +5310,28 @@
   <p:clrMapOvr>
     <a:masterClrMapping/>
   </p:clrMapOvr>
+  <p:timing>
+    <p:tnLst>
+      <p:par>
+        <p:cTn id="1" dur="indefinite" restart="never" nodeType="tmRoot">
+          <p:childTnLst>
+            <p:video>
+              <p:cMediaNode vol="80000">
+                <p:cTn id="2" fill="hold" display="0">
+                  <p:stCondLst>
+                    <p:cond delay="indefinite"/>
+                  </p:stCondLst>
+                </p:cTn>
+                <p:tgtEl>
+                  <p:spTgt spid="5"/>
+                </p:tgtEl>
+              </p:cMediaNode>
+            </p:video>
+          </p:childTnLst>
+        </p:cTn>
+      </p:par>
+    </p:tnLst>
+  </p:timing>
 </p:sld>
 </file>
 
@@ -5138,7 +5360,7 @@
             <a:avLst/>
           </a:prstGeom>
           <a:solidFill>
-            <a:srgbClr val="0B0D13"/>
+            <a:srgbClr val="FFFFFF"/>
           </a:solidFill>
           <a:ln>
             <a:noFill/>
@@ -5197,7 +5419,7 @@
             <a:r>
               <a:rPr sz="2600" b="1">
                 <a:solidFill>
-                  <a:srgbClr val="FF7A34"/>
+                  <a:srgbClr val="C85610"/>
                 </a:solidFill>
                 <a:latin typeface="Calibri"/>
               </a:rPr>
@@ -5236,7 +5458,7 @@
             <a:r>
               <a:rPr sz="2600" b="1">
                 <a:solidFill>
-                  <a:srgbClr val="ECE9E3"/>
+                  <a:srgbClr val="1A1A1F"/>
                 </a:solidFill>
                 <a:latin typeface="Calibri"/>
               </a:rPr>
@@ -5247,29 +5469,38 @@
       </p:sp>
       <p:pic>
         <p:nvPicPr>
-          <p:cNvPr id="5" name="Picture 4" descr="flame_xt.png"/>
+          <p:cNvPr id="5" name="prop.mp4">
+            <a:hlinkClick r:id="" action="ppaction://media"/>
+          </p:cNvPr>
           <p:cNvPicPr>
             <a:picLocks noChangeAspect="1"/>
           </p:cNvPicPr>
-          <p:nvPr/>
+          <p:nvPr>
+            <a:videoFile r:link="rId3"/>
+            <p:extLst>
+              <p:ext uri="{DAA4B4D4-6D71-4841-9C94-3DE7FCFB9230}">
+                <p14:media xmlns:p14="http://schemas.microsoft.com/office/powerpoint/2010/main" r:embed="rId2"/>
+              </p:ext>
+            </p:extLst>
+          </p:nvPr>
         </p:nvPicPr>
         <p:blipFill>
-          <a:blip r:embed="rId2"/>
+          <a:blip r:embed="rId4"/>
           <a:stretch>
             <a:fillRect/>
           </a:stretch>
         </p:blipFill>
         <p:spPr>
           <a:xfrm>
-            <a:off x="868680" y="1417320"/>
-            <a:ext cx="6583680" cy="4937760"/>
+            <a:off x="1116695" y="1463040"/>
+            <a:ext cx="6087649" cy="4937760"/>
           </a:xfrm>
           <a:prstGeom prst="rect">
             <a:avLst/>
           </a:prstGeom>
           <a:ln w="12700">
             <a:solidFill>
-              <a:srgbClr val="2A2E38"/>
+              <a:srgbClr val="CFD3DA"/>
             </a:solidFill>
           </a:ln>
         </p:spPr>
@@ -5282,8 +5513,8 @@
         </p:nvSpPr>
         <p:spPr>
           <a:xfrm>
-            <a:off x="8092440" y="1554480"/>
-            <a:ext cx="3657600" cy="4572000"/>
+            <a:off x="8138160" y="1600200"/>
+            <a:ext cx="3611880" cy="4572000"/>
           </a:xfrm>
           <a:prstGeom prst="rect">
             <a:avLst/>
@@ -5304,11 +5535,11 @@
             <a:r>
               <a:rPr sz="1600" b="0">
                 <a:solidFill>
-                  <a:srgbClr val="9AA0AB"/>
+                  <a:srgbClr val="52525B"/>
                 </a:solidFill>
                 <a:latin typeface="Calibri"/>
               </a:rPr>
-              <a:t>A premixed H₂/O₂/Ar deflagration propagating at ~18.6 m/s with full multicomponent transport and finite-rate chemistry — the slow, diffusion-controlled counterpart to the shock-driven detonations, shown as an x–t diagram of the reaction front.</a:t>
+              <a:t>A premixed H₂/O₂/Ar deflagration propagating at ~18.6 m/s with full multicomponent transport and finite-rate chemistry — the slow, diffusion-controlled counterpart to the shock-driven detonations.</a:t>
             </a:r>
           </a:p>
         </p:txBody>
@@ -5318,6 +5549,28 @@
   <p:clrMapOvr>
     <a:masterClrMapping/>
   </p:clrMapOvr>
+  <p:timing>
+    <p:tnLst>
+      <p:par>
+        <p:cTn id="1" dur="indefinite" restart="never" nodeType="tmRoot">
+          <p:childTnLst>
+            <p:video>
+              <p:cMediaNode vol="80000">
+                <p:cTn id="2" fill="hold" display="0">
+                  <p:stCondLst>
+                    <p:cond delay="indefinite"/>
+                  </p:stCondLst>
+                </p:cTn>
+                <p:tgtEl>
+                  <p:spTgt spid="5"/>
+                </p:tgtEl>
+              </p:cMediaNode>
+            </p:video>
+          </p:childTnLst>
+        </p:cTn>
+      </p:par>
+    </p:tnLst>
+  </p:timing>
 </p:sld>
 </file>
 

</xml_diff>

<commit_message>
docs: add 3D cellular detonation slide to showcase deck
</commit_message>
<xml_diff>
--- a/MFC_combustion_showcase.pptx
+++ b/MFC_combustion_showcase.pptx
@@ -15,6 +15,7 @@
     <p:sldId id="263" r:id="rId14"/>
     <p:sldId id="264" r:id="rId15"/>
     <p:sldId id="265" r:id="rId16"/>
+    <p:sldId id="266" r:id="rId17"/>
   </p:sldIdLst>
   <p:sldSz cx="12191695" cy="6858000" type="screen4x3"/>
   <p:notesSz cx="6858000" cy="9144000"/>
@@ -3328,6 +3329,245 @@
         </p:nvSpPr>
         <p:spPr>
           <a:xfrm>
+            <a:off x="502920" y="292608"/>
+            <a:ext cx="822960" cy="548640"/>
+          </a:xfrm>
+          <a:prstGeom prst="rect">
+            <a:avLst/>
+          </a:prstGeom>
+          <a:noFill/>
+        </p:spPr>
+        <p:txBody>
+          <a:bodyPr wrap="square" anchor="t">
+            <a:spAutoFit/>
+          </a:bodyPr>
+          <a:lstStyle/>
+          <a:p>
+            <a:pPr algn="l">
+              <a:lnSpc>
+                <a:spcPct val="100000"/>
+              </a:lnSpc>
+            </a:pPr>
+            <a:r>
+              <a:rPr sz="2600" b="1">
+                <a:solidFill>
+                  <a:srgbClr val="C85610"/>
+                </a:solidFill>
+                <a:latin typeface="Calibri"/>
+              </a:rPr>
+              <a:t>09</a:t>
+            </a:r>
+          </a:p>
+        </p:txBody>
+      </p:sp>
+      <p:sp>
+        <p:nvSpPr>
+          <p:cNvPr id="4" name="TextBox 3"/>
+          <p:cNvSpPr txBox="1"/>
+          <p:nvPr/>
+        </p:nvSpPr>
+        <p:spPr>
+          <a:xfrm>
+            <a:off x="1325880" y="310896"/>
+            <a:ext cx="10332720" cy="822960"/>
+          </a:xfrm>
+          <a:prstGeom prst="rect">
+            <a:avLst/>
+          </a:prstGeom>
+          <a:noFill/>
+        </p:spPr>
+        <p:txBody>
+          <a:bodyPr wrap="square" anchor="t">
+            <a:spAutoFit/>
+          </a:bodyPr>
+          <a:lstStyle/>
+          <a:p>
+            <a:pPr algn="l">
+              <a:lnSpc>
+                <a:spcPct val="100000"/>
+              </a:lnSpc>
+            </a:pPr>
+            <a:r>
+              <a:rPr sz="2600" b="1">
+                <a:solidFill>
+                  <a:srgbClr val="1A1A1F"/>
+                </a:solidFill>
+                <a:latin typeface="Calibri"/>
+              </a:rPr>
+              <a:t>1D premixed propellant flame</a:t>
+            </a:r>
+          </a:p>
+        </p:txBody>
+      </p:sp>
+      <p:pic>
+        <p:nvPicPr>
+          <p:cNvPr id="5" name="prop.mp4">
+            <a:hlinkClick r:id="" action="ppaction://media"/>
+          </p:cNvPr>
+          <p:cNvPicPr>
+            <a:picLocks noChangeAspect="1"/>
+          </p:cNvPicPr>
+          <p:nvPr>
+            <a:videoFile r:link="rId3"/>
+            <p:extLst>
+              <p:ext uri="{DAA4B4D4-6D71-4841-9C94-3DE7FCFB9230}">
+                <p14:media xmlns:p14="http://schemas.microsoft.com/office/powerpoint/2010/main" r:embed="rId2"/>
+              </p:ext>
+            </p:extLst>
+          </p:nvPr>
+        </p:nvPicPr>
+        <p:blipFill>
+          <a:blip r:embed="rId4"/>
+          <a:stretch>
+            <a:fillRect/>
+          </a:stretch>
+        </p:blipFill>
+        <p:spPr>
+          <a:xfrm>
+            <a:off x="1116695" y="1463040"/>
+            <a:ext cx="6087649" cy="4937760"/>
+          </a:xfrm>
+          <a:prstGeom prst="rect">
+            <a:avLst/>
+          </a:prstGeom>
+          <a:ln w="12700">
+            <a:solidFill>
+              <a:srgbClr val="CFD3DA"/>
+            </a:solidFill>
+          </a:ln>
+        </p:spPr>
+      </p:pic>
+      <p:sp>
+        <p:nvSpPr>
+          <p:cNvPr id="6" name="TextBox 5"/>
+          <p:cNvSpPr txBox="1"/>
+          <p:nvPr/>
+        </p:nvSpPr>
+        <p:spPr>
+          <a:xfrm>
+            <a:off x="8138160" y="1600200"/>
+            <a:ext cx="3611880" cy="4572000"/>
+          </a:xfrm>
+          <a:prstGeom prst="rect">
+            <a:avLst/>
+          </a:prstGeom>
+          <a:noFill/>
+        </p:spPr>
+        <p:txBody>
+          <a:bodyPr wrap="square" anchor="t">
+            <a:normAutofit/>
+          </a:bodyPr>
+          <a:lstStyle/>
+          <a:p>
+            <a:pPr algn="l">
+              <a:lnSpc>
+                <a:spcPct val="112000"/>
+              </a:lnSpc>
+            </a:pPr>
+            <a:r>
+              <a:rPr sz="1600" b="0">
+                <a:solidFill>
+                  <a:srgbClr val="52525B"/>
+                </a:solidFill>
+                <a:latin typeface="Calibri"/>
+              </a:rPr>
+              <a:t>A premixed H₂/O₂/Ar deflagration propagating at ~18.6 m/s with full multicomponent transport and finite-rate chemistry — the slow, diffusion-controlled counterpart to the shock-driven detonations.</a:t>
+            </a:r>
+          </a:p>
+        </p:txBody>
+      </p:sp>
+    </p:spTree>
+  </p:cSld>
+  <p:clrMapOvr>
+    <a:masterClrMapping/>
+  </p:clrMapOvr>
+  <p:timing>
+    <p:tnLst>
+      <p:par>
+        <p:cTn id="1" dur="indefinite" restart="never" nodeType="tmRoot">
+          <p:childTnLst>
+            <p:video>
+              <p:cMediaNode vol="80000">
+                <p:cTn id="2" fill="hold" display="0">
+                  <p:stCondLst>
+                    <p:cond delay="indefinite"/>
+                  </p:stCondLst>
+                </p:cTn>
+                <p:tgtEl>
+                  <p:spTgt spid="5"/>
+                </p:tgtEl>
+              </p:cMediaNode>
+            </p:video>
+          </p:childTnLst>
+        </p:cTn>
+      </p:par>
+    </p:tnLst>
+  </p:timing>
+</p:sld>
+</file>
+
+<file path=ppt/slides/slide11.xml><?xml version="1.0" encoding="utf-8"?>
+<p:sld xmlns:a="http://schemas.openxmlformats.org/drawingml/2006/main" xmlns:p="http://schemas.openxmlformats.org/presentationml/2006/main" xmlns:r="http://schemas.openxmlformats.org/officeDocument/2006/relationships">
+  <p:cSld>
+    <p:spTree>
+      <p:nvGrpSpPr>
+        <p:cNvPr id="1" name=""/>
+        <p:cNvGrpSpPr/>
+        <p:nvPr/>
+      </p:nvGrpSpPr>
+      <p:grpSpPr/>
+      <p:sp>
+        <p:nvSpPr>
+          <p:cNvPr id="2" name="Rectangle 1"/>
+          <p:cNvSpPr/>
+          <p:nvPr/>
+        </p:nvSpPr>
+        <p:spPr>
+          <a:xfrm>
+            <a:off x="0" y="0"/>
+            <a:ext cx="12191695" cy="6858000"/>
+          </a:xfrm>
+          <a:prstGeom prst="rect">
+            <a:avLst/>
+          </a:prstGeom>
+          <a:solidFill>
+            <a:srgbClr val="FFFFFF"/>
+          </a:solidFill>
+          <a:ln>
+            <a:noFill/>
+          </a:ln>
+          <a:effectLst/>
+        </p:spPr>
+        <p:style>
+          <a:lnRef idx="1">
+            <a:schemeClr val="accent1"/>
+          </a:lnRef>
+          <a:fillRef idx="3">
+            <a:schemeClr val="accent1"/>
+          </a:fillRef>
+          <a:effectRef idx="2">
+            <a:schemeClr val="accent1"/>
+          </a:effectRef>
+          <a:fontRef idx="minor">
+            <a:schemeClr val="lt1"/>
+          </a:fontRef>
+        </p:style>
+        <p:txBody>
+          <a:bodyPr rtlCol="0" anchor="ctr"/>
+          <a:lstStyle/>
+          <a:p>
+            <a:pPr algn="ctr"/>
+          </a:p>
+        </p:txBody>
+      </p:sp>
+      <p:sp>
+        <p:nvSpPr>
+          <p:cNvPr id="3" name="TextBox 2"/>
+          <p:cNvSpPr txBox="1"/>
+          <p:nvPr/>
+        </p:nvSpPr>
+        <p:spPr>
+          <a:xfrm>
             <a:off x="502920" y="274320"/>
             <a:ext cx="1280160" cy="548640"/>
           </a:xfrm>
@@ -3911,14 +4151,14 @@
                 </a:solidFill>
                 <a:latin typeface="Calibri"/>
               </a:rPr>
-              <a:t>Detonation diffracting around an obstacle</a:t>
+              <a:t>3D cellular detonation</a:t>
             </a:r>
           </a:p>
         </p:txBody>
       </p:sp>
       <p:pic>
         <p:nvPicPr>
-          <p:cNvPr id="5" name="ell.mp4">
+          <p:cNvPr id="5" name="det3d.mp4">
             <a:hlinkClick r:id="" action="ppaction://media"/>
           </p:cNvPr>
           <p:cNvPicPr>
@@ -3942,7 +4182,7 @@
         <p:spPr>
           <a:xfrm>
             <a:off x="502920" y="1463040"/>
-            <a:ext cx="7315200" cy="1999488"/>
+            <a:ext cx="7315200" cy="4389120"/>
           </a:xfrm>
           <a:prstGeom prst="rect">
             <a:avLst/>
@@ -3988,7 +4228,7 @@
                 </a:solidFill>
                 <a:latin typeface="Calibri"/>
               </a:rPr>
-              <a:t>The detonation runs into a rotated-ellipse immersed boundary and wraps around it, staying vigorous (~3400 K). This surfaced a solver finding: CFL-adaptive time-stepping drives the timestep to NaN and silently hangs at the super-heated impact, while a fixed timestep sails through the diffraction.</a:t>
+              <a:t>The same physics run in 3D on the four GPUs (millions of cells): a self-sustained detonation with a corrugated three-dimensional front, shown here as an OH-radical isosurface tracking the reaction zone as it sweeps down the channel. The transverse waves imprint the classic cellular soot-foil pattern — the diamond fish-scale structure that is the fingerprint of a detonation.</a:t>
             </a:r>
           </a:p>
         </p:txBody>
@@ -4150,53 +4390,14 @@
                 </a:solidFill>
                 <a:latin typeface="Calibri"/>
               </a:rPr>
-              <a:t>Condensed-phase detonation — a solid explosive</a:t>
-            </a:r>
-          </a:p>
-        </p:txBody>
-      </p:sp>
-      <p:sp>
-        <p:nvSpPr>
-          <p:cNvPr id="5" name="TextBox 4"/>
-          <p:cNvSpPr txBox="1"/>
-          <p:nvPr/>
-        </p:nvSpPr>
-        <p:spPr>
-          <a:xfrm>
-            <a:off x="1371600" y="932688"/>
-            <a:ext cx="5486400" cy="320040"/>
-          </a:xfrm>
-          <a:prstGeom prst="rect">
-            <a:avLst/>
-          </a:prstGeom>
-          <a:noFill/>
-        </p:spPr>
-        <p:txBody>
-          <a:bodyPr wrap="square" anchor="t">
-            <a:spAutoFit/>
-          </a:bodyPr>
-          <a:lstStyle/>
-          <a:p>
-            <a:pPr algn="l">
-              <a:lnSpc>
-                <a:spcPct val="100000"/>
-              </a:lnSpc>
-            </a:pPr>
-            <a:r>
-              <a:rPr sz="1100" b="1">
-                <a:solidFill>
-                  <a:srgbClr val="A96E08"/>
-                </a:solidFill>
-                <a:latin typeface="Calibri"/>
-              </a:rPr>
-              <a:t>● NEW CAPABILITY</a:t>
+              <a:t>Detonation diffracting around an obstacle</a:t>
             </a:r>
           </a:p>
         </p:txBody>
       </p:sp>
       <p:pic>
         <p:nvPicPr>
-          <p:cNvPr id="6" name="rb.mp4">
+          <p:cNvPr id="5" name="ell.mp4">
             <a:hlinkClick r:id="" action="ppaction://media"/>
           </p:cNvPr>
           <p:cNvPicPr>
@@ -4220,7 +4421,7 @@
         <p:spPr>
           <a:xfrm>
             <a:off x="502920" y="1463040"/>
-            <a:ext cx="7315200" cy="3103968"/>
+            <a:ext cx="7315200" cy="1999488"/>
           </a:xfrm>
           <a:prstGeom prst="rect">
             <a:avLst/>
@@ -4234,7 +4435,7 @@
       </p:pic>
       <p:sp>
         <p:nvSpPr>
-          <p:cNvPr id="7" name="TextBox 6"/>
+          <p:cNvPr id="6" name="TextBox 5"/>
           <p:cNvSpPr txBox="1"/>
           <p:nvPr/>
         </p:nvSpPr>
@@ -4266,7 +4467,7 @@
                 </a:solidFill>
                 <a:latin typeface="Calibri"/>
               </a:rPr>
-              <a:t>A programmed pressure burn converts reactant to product on the multi-fluid model (no ideal-gas chemistry): the two fluids share an EOS and differ only in reference energy, releasing heat through the mixture equation of state. A self-sustained ~7 km/s detonation forms — von Neumann spike, ZND reaction zone, Taylor rarefaction — bypassing the Cantera single-fluid lock.</a:t>
+              <a:t>The detonation runs into a rotated-ellipse immersed boundary and wraps around it, staying vigorous (~3400 K). This surfaced a solver finding: CFL-adaptive time-stepping drives the timestep to NaN and silently hangs at the super-heated impact, while a fixed timestep sails through the diffraction.</a:t>
             </a:r>
           </a:p>
         </p:txBody>
@@ -4289,7 +4490,7 @@
                   </p:stCondLst>
                 </p:cTn>
                 <p:tgtEl>
-                  <p:spTgt spid="6"/>
+                  <p:spTgt spid="5"/>
                 </p:tgtEl>
               </p:cMediaNode>
             </p:video>
@@ -4428,7 +4629,7 @@
                 </a:solidFill>
                 <a:latin typeface="Calibri"/>
               </a:rPr>
-              <a:t>Burning solid-fuel grain</a:t>
+              <a:t>Condensed-phase detonation — a solid explosive</a:t>
             </a:r>
           </a:p>
         </p:txBody>
@@ -4474,7 +4675,7 @@
       </p:sp>
       <p:pic>
         <p:nvPicPr>
-          <p:cNvPr id="6" name="grain.mp4">
+          <p:cNvPr id="6" name="rb.mp4">
             <a:hlinkClick r:id="" action="ppaction://media"/>
           </p:cNvPr>
           <p:cNvPicPr>
@@ -4497,8 +4698,8 @@
         </p:blipFill>
         <p:spPr>
           <a:xfrm>
-            <a:off x="574766" y="1463040"/>
-            <a:ext cx="7171508" cy="4937760"/>
+            <a:off x="502920" y="1463040"/>
+            <a:ext cx="7315200" cy="3103968"/>
           </a:xfrm>
           <a:prstGeom prst="rect">
             <a:avLst/>
@@ -4544,7 +4745,7 @@
                 </a:solidFill>
                 <a:latin typeface="Calibri"/>
               </a:rPr>
-              <a:t>A solid cylinder injects H₂ off its surface into a hot O₂/Ar chamber; the fuel auto-ignites and anchors a surface diffusion flame (~2700 K). Enabled by two new immersed-boundary knobs — wall-normal blowing and injected-species — that let a solid surface transpire and inject fuel.</a:t>
+              <a:t>A programmed pressure burn converts reactant to product on the multi-fluid model (no ideal-gas chemistry): the two fluids share an EOS and differ only in reference energy, releasing heat through the mixture equation of state. A self-sustained ~7 km/s detonation forms — von Neumann spike, ZND reaction zone, Taylor rarefaction — bypassing the Cantera single-fluid lock.</a:t>
             </a:r>
           </a:p>
         </p:txBody>
@@ -4706,7 +4907,7 @@
                 </a:solidFill>
                 <a:latin typeface="Calibri"/>
               </a:rPr>
-              <a:t>Internal ballistics — pressure-coupled burn</a:t>
+              <a:t>Burning solid-fuel grain</a:t>
             </a:r>
           </a:p>
         </p:txBody>
@@ -4752,7 +4953,7 @@
       </p:sp>
       <p:pic>
         <p:nvPicPr>
-          <p:cNvPr id="6" name="ib.mp4">
+          <p:cNvPr id="6" name="grain.mp4">
             <a:hlinkClick r:id="" action="ppaction://media"/>
           </p:cNvPr>
           <p:cNvPicPr>
@@ -4775,8 +4976,8 @@
         </p:blipFill>
         <p:spPr>
           <a:xfrm>
-            <a:off x="627159" y="1463040"/>
-            <a:ext cx="7066721" cy="4937760"/>
+            <a:off x="574766" y="1463040"/>
+            <a:ext cx="7171508" cy="4937760"/>
           </a:xfrm>
           <a:prstGeom prst="rect">
             <a:avLst/>
@@ -4822,7 +5023,7 @@
                 </a:solidFill>
                 <a:latin typeface="Calibri"/>
               </a:rPr>
-              <a:t>A Vieille's-law burn rate (v ∝ pⁿ) turns the closed chamber into a feedback loop: combustion raises the pressure, which raises the burn rate, which raises the pressure — the defining signature of solid-rocket internal ballistics, reproduced from first-principles CFD.</a:t>
+              <a:t>A solid cylinder injects H₂ off its surface into a hot O₂/Ar chamber; the fuel auto-ignites and anchors a surface diffusion flame (~2700 K). Enabled by two new immersed-boundary knobs — wall-normal blowing and injected-species — that let a solid surface transpire and inject fuel.</a:t>
             </a:r>
           </a:p>
         </p:txBody>
@@ -4984,14 +5185,53 @@
                 </a:solidFill>
                 <a:latin typeface="Calibri"/>
               </a:rPr>
-              <a:t>Hybrid-rocket fuel slab</a:t>
+              <a:t>Internal ballistics — pressure-coupled burn</a:t>
+            </a:r>
+          </a:p>
+        </p:txBody>
+      </p:sp>
+      <p:sp>
+        <p:nvSpPr>
+          <p:cNvPr id="5" name="TextBox 4"/>
+          <p:cNvSpPr txBox="1"/>
+          <p:nvPr/>
+        </p:nvSpPr>
+        <p:spPr>
+          <a:xfrm>
+            <a:off x="1371600" y="932688"/>
+            <a:ext cx="5486400" cy="320040"/>
+          </a:xfrm>
+          <a:prstGeom prst="rect">
+            <a:avLst/>
+          </a:prstGeom>
+          <a:noFill/>
+        </p:spPr>
+        <p:txBody>
+          <a:bodyPr wrap="square" anchor="t">
+            <a:spAutoFit/>
+          </a:bodyPr>
+          <a:lstStyle/>
+          <a:p>
+            <a:pPr algn="l">
+              <a:lnSpc>
+                <a:spcPct val="100000"/>
+              </a:lnSpc>
+            </a:pPr>
+            <a:r>
+              <a:rPr sz="1100" b="1">
+                <a:solidFill>
+                  <a:srgbClr val="A96E08"/>
+                </a:solidFill>
+                <a:latin typeface="Calibri"/>
+              </a:rPr>
+              <a:t>● NEW CAPABILITY</a:t>
             </a:r>
           </a:p>
         </p:txBody>
       </p:sp>
       <p:pic>
         <p:nvPicPr>
-          <p:cNvPr id="5" name="hyb.mp4">
+          <p:cNvPr id="6" name="ib.mp4">
             <a:hlinkClick r:id="" action="ppaction://media"/>
           </p:cNvPr>
           <p:cNvPicPr>
@@ -5014,8 +5254,8 @@
         </p:blipFill>
         <p:spPr>
           <a:xfrm>
-            <a:off x="502920" y="1463040"/>
-            <a:ext cx="7315200" cy="2909824"/>
+            <a:off x="627159" y="1463040"/>
+            <a:ext cx="7066721" cy="4937760"/>
           </a:xfrm>
           <a:prstGeom prst="rect">
             <a:avLst/>
@@ -5029,7 +5269,7 @@
       </p:pic>
       <p:sp>
         <p:nvSpPr>
-          <p:cNvPr id="6" name="TextBox 5"/>
+          <p:cNvPr id="7" name="TextBox 6"/>
           <p:cNvSpPr txBox="1"/>
           <p:nvPr/>
         </p:nvSpPr>
@@ -5061,7 +5301,7 @@
                 </a:solidFill>
                 <a:latin typeface="Calibri"/>
               </a:rPr>
-              <a:t>A wall strip injects H₂ into a hot O₂/Ar crossflow, forming a boundary-layer diffusion flame (~2660 K) that lifts off the wall and burns downstream — the essential hybrid-rocket picture of fuel blowing off a surface into an oxidizer stream, at high resolution.</a:t>
+              <a:t>A Vieille's-law burn rate (v ∝ pⁿ) turns the closed chamber into a feedback loop: combustion raises the pressure, which raises the burn rate, which raises the pressure — the defining signature of solid-rocket internal ballistics, reproduced from first-principles CFD.</a:t>
             </a:r>
           </a:p>
         </p:txBody>
@@ -5084,7 +5324,7 @@
                   </p:stCondLst>
                 </p:cTn>
                 <p:tgtEl>
-                  <p:spTgt spid="5"/>
+                  <p:spTgt spid="6"/>
                 </p:tgtEl>
               </p:cMediaNode>
             </p:video>
@@ -5223,14 +5463,14 @@
                 </a:solidFill>
                 <a:latin typeface="Calibri"/>
               </a:rPr>
-              <a:t>Bluff-body flame holder</a:t>
+              <a:t>Hybrid-rocket fuel slab</a:t>
             </a:r>
           </a:p>
         </p:txBody>
       </p:sp>
       <p:pic>
         <p:nvPicPr>
-          <p:cNvPr id="5" name="fh.mp4">
+          <p:cNvPr id="5" name="hyb.mp4">
             <a:hlinkClick r:id="" action="ppaction://media"/>
           </p:cNvPr>
           <p:cNvPicPr>
@@ -5254,7 +5494,7 @@
         <p:spPr>
           <a:xfrm>
             <a:off x="502920" y="1463040"/>
-            <a:ext cx="7315200" cy="3576320"/>
+            <a:ext cx="7315200" cy="2909824"/>
           </a:xfrm>
           <a:prstGeom prst="rect">
             <a:avLst/>
@@ -5300,7 +5540,7 @@
                 </a:solidFill>
                 <a:latin typeface="Calibri"/>
               </a:rPr>
-              <a:t>A fuel-injecting cylinder anchors a flame in its recirculating wake (~2630 K). The freestream carries no fuel, so combustion can only stabilize where the injected H₂ meets the oxidizer behind the body — the classic afterburner/ramjet flame-holder configuration.</a:t>
+              <a:t>A wall strip injects H₂ into a hot O₂/Ar crossflow, forming a boundary-layer diffusion flame (~2660 K) that lifts off the wall and burns downstream — the essential hybrid-rocket picture of fuel blowing off a surface into an oxidizer stream, at high resolution.</a:t>
             </a:r>
           </a:p>
         </p:txBody>
@@ -5462,14 +5702,14 @@
                 </a:solidFill>
                 <a:latin typeface="Calibri"/>
               </a:rPr>
-              <a:t>1D premixed propellant flame</a:t>
+              <a:t>Bluff-body flame holder</a:t>
             </a:r>
           </a:p>
         </p:txBody>
       </p:sp>
       <p:pic>
         <p:nvPicPr>
-          <p:cNvPr id="5" name="prop.mp4">
+          <p:cNvPr id="5" name="fh.mp4">
             <a:hlinkClick r:id="" action="ppaction://media"/>
           </p:cNvPr>
           <p:cNvPicPr>
@@ -5492,8 +5732,8 @@
         </p:blipFill>
         <p:spPr>
           <a:xfrm>
-            <a:off x="1116695" y="1463040"/>
-            <a:ext cx="6087649" cy="4937760"/>
+            <a:off x="502920" y="1463040"/>
+            <a:ext cx="7315200" cy="3576320"/>
           </a:xfrm>
           <a:prstGeom prst="rect">
             <a:avLst/>
@@ -5539,7 +5779,7 @@
                 </a:solidFill>
                 <a:latin typeface="Calibri"/>
               </a:rPr>
-              <a:t>A premixed H₂/O₂/Ar deflagration propagating at ~18.6 m/s with full multicomponent transport and finite-rate chemistry — the slow, diffusion-controlled counterpart to the shock-driven detonations.</a:t>
+              <a:t>A fuel-injecting cylinder anchors a flame in its recirculating wake (~2630 K). The freestream carries no fuel, so combustion can only stabilize where the injected H₂ meets the oxidizer behind the body — the classic afterburner/ramjet flame-holder configuration.</a:t>
             </a:r>
           </a:p>
         </p:txBody>

</xml_diff>

<commit_message>
docs: use soot foil (not isosurface) for the 3D detonation slide
</commit_message>
<xml_diff>
--- a/MFC_combustion_showcase.pptx
+++ b/MFC_combustion_showcase.pptx
@@ -4151,14 +4151,14 @@
                 </a:solidFill>
                 <a:latin typeface="Calibri"/>
               </a:rPr>
-              <a:t>3D cellular detonation</a:t>
+              <a:t>3D detonation — cellular soot foil</a:t>
             </a:r>
           </a:p>
         </p:txBody>
       </p:sp>
       <p:pic>
         <p:nvPicPr>
-          <p:cNvPr id="5" name="det3d.mp4">
+          <p:cNvPr id="5" name="sootfoil.mp4">
             <a:hlinkClick r:id="" action="ppaction://media"/>
           </p:cNvPr>
           <p:cNvPicPr>
@@ -4182,7 +4182,7 @@
         <p:spPr>
           <a:xfrm>
             <a:off x="502920" y="1463040"/>
-            <a:ext cx="7315200" cy="4389120"/>
+            <a:ext cx="7315200" cy="2072640"/>
           </a:xfrm>
           <a:prstGeom prst="rect">
             <a:avLst/>
@@ -4228,7 +4228,7 @@
                 </a:solidFill>
                 <a:latin typeface="Calibri"/>
               </a:rPr>
-              <a:t>The same physics run in 3D on the four GPUs (millions of cells): a self-sustained detonation with a corrugated three-dimensional front, shown here as an OH-radical isosurface tracking the reaction zone as it sweeps down the channel. The transverse waves imprint the classic cellular soot-foil pattern — the diamond fish-scale structure that is the fingerprint of a detonation.</a:t>
+              <a:t>The same case run in 3D on the four GPUs (millions of cells). Recording the peak pressure reached at every point traces the soot foil — the diamond fish-scale imprint of the detonation's transverse waves, forming here as the front sweeps down the channel. This diamond-cell pattern is the classic fingerprint of a detonation's cellular structure.</a:t>
             </a:r>
           </a:p>
         </p:txBody>

</xml_diff>

<commit_message>
docs: refresh showcase deck with true 3D cut-plane detonation view
</commit_message>
<xml_diff>
--- a/MFC_combustion_showcase.pptx
+++ b/MFC_combustion_showcase.pptx
@@ -4151,14 +4151,14 @@
                 </a:solidFill>
                 <a:latin typeface="Calibri"/>
               </a:rPr>
-              <a:t>3D detonation — cellular soot foil</a:t>
+              <a:t>3D cellular detonation on four GPUs</a:t>
             </a:r>
           </a:p>
         </p:txBody>
       </p:sp>
       <p:pic>
         <p:nvPicPr>
-          <p:cNvPr id="5" name="sootfoil.mp4">
+          <p:cNvPr id="5" name="det3d.mp4">
             <a:hlinkClick r:id="" action="ppaction://media"/>
           </p:cNvPr>
           <p:cNvPicPr>
@@ -4182,7 +4182,7 @@
         <p:spPr>
           <a:xfrm>
             <a:off x="502920" y="1463040"/>
-            <a:ext cx="7315200" cy="2072640"/>
+            <a:ext cx="7315200" cy="4632960"/>
           </a:xfrm>
           <a:prstGeom prst="rect">
             <a:avLst/>
@@ -4228,7 +4228,7 @@
                 </a:solidFill>
                 <a:latin typeface="Calibri"/>
               </a:rPr>
-              <a:t>The same case run in 3D on the four GPUs (millions of cells). Recording the peak pressure reached at every point traces the soot foil — the diamond fish-scale imprint of the detonation's transverse waves, forming here as the front sweeps down the channel. This diamond-cell pattern is the classic fingerprint of a detonation's cellular structure.</a:t>
+              <a:t>The same case run in 3D on the four A100s (millions of cells). Two orthogonal temperature cut-planes slice the domain box: hot burned products trail the detonation front as it sweeps into the dark unreacted mixture ahead. Recording the peak pressure at every point traces the soot foil — the diamond fish-scale imprint of the transverse waves, the classic fingerprint of a cellular detonation.</a:t>
             </a:r>
           </a:p>
         </p:txBody>

</xml_diff>

<commit_message>
docs: use half-domain-cut 3D detonation view in showcase deck
</commit_message>
<xml_diff>
--- a/MFC_combustion_showcase.pptx
+++ b/MFC_combustion_showcase.pptx
@@ -4182,7 +4182,7 @@
         <p:spPr>
           <a:xfrm>
             <a:off x="502920" y="1463040"/>
-            <a:ext cx="7315200" cy="4632960"/>
+            <a:ext cx="7315200" cy="3543300"/>
           </a:xfrm>
           <a:prstGeom prst="rect">
             <a:avLst/>
@@ -4228,7 +4228,7 @@
                 </a:solidFill>
                 <a:latin typeface="Calibri"/>
               </a:rPr>
-              <a:t>The same case run in 3D on the four A100s (millions of cells). Two orthogonal temperature cut-planes slice the domain box: hot burned products trail the detonation front as it sweeps into the dark unreacted mixture ahead. Recording the peak pressure at every point traces the soot foil — the diamond fish-scale imprint of the transverse waves, the classic fingerprint of a cellular detonation.</a:t>
+              <a:t>The same case run in 3D on the four A100s (millions of cells). The domain is cut in half to expose the internal temperature field: hot burned products trail the corrugated detonation front as it sweeps into the dark unreacted mixture ahead, the reacting front picked out in blue. Recording the peak pressure at every point traces the soot foil — the diamond fish-scale imprint of the transverse waves, the classic fingerprint of a cellular detonation.</a:t>
             </a:r>
           </a:p>
         </p:txBody>

</xml_diff>

<commit_message>
examples: add resolution knob to burning grain; refresh deck with 2x-resolution 2D cases
</commit_message>
<xml_diff>
--- a/MFC_combustion_showcase.pptx
+++ b/MFC_combustion_showcase.pptx
@@ -3943,7 +3943,7 @@
         <p:spPr>
           <a:xfrm>
             <a:off x="502920" y="1463040"/>
-            <a:ext cx="7315200" cy="4590553"/>
+            <a:ext cx="7315200" cy="2458356"/>
           </a:xfrm>
           <a:prstGeom prst="rect">
             <a:avLst/>
@@ -4976,8 +4976,8 @@
         </p:blipFill>
         <p:spPr>
           <a:xfrm>
-            <a:off x="2642225" y="1463040"/>
-            <a:ext cx="3036590" cy="4937760"/>
+            <a:off x="1206627" y="1463040"/>
+            <a:ext cx="5907785" cy="4937760"/>
           </a:xfrm>
           <a:prstGeom prst="rect">
             <a:avLst/>
@@ -5732,8 +5732,8 @@
         </p:blipFill>
         <p:spPr>
           <a:xfrm>
-            <a:off x="1344773" y="1463040"/>
-            <a:ext cx="5631494" cy="4937760"/>
+            <a:off x="502920" y="1463040"/>
+            <a:ext cx="7315200" cy="3371353"/>
           </a:xfrm>
           <a:prstGeom prst="rect">
             <a:avLst/>

</xml_diff>